<commit_message>
Mini-progetto finale a casa, con presentazione all'ultimo incontro
- E4: tappe, consegna e presentazione di circa 10 minuti
- L7: la scelta di domanda e dati diventa compito obbligatorio
- L8: nuova slide che assegna il progetto; compito aggiornato
- README: calendario da novembre a gennaio

Co-Authored-By: Claude Opus 5.5 <noreply@anthropic.com>
Claude-Session: https://claude.ai/code/session_014CzWDFXvYNxqLeD99LSN3G
</commit_message>
<xml_diff>
--- a/lezioni/L07_internet_regressione/slide.pptx
+++ b/lezioni/L07_internet_regressione/slide.pptx
@@ -113,25 +113,25 @@
   <p:extLst>
     <p:ext uri="{521415D9-36F7-43E2-AB2F-B90AF26B5E84}">
       <p14:sectionLst xmlns:p14="http://schemas.microsoft.com/office/powerpoint/2010/main">
-        <p14:section name="Apertura" id="{2b0e1a9c-7225-8cd0-c471-f946b8dea045}">
+        <p14:section name="Apertura" id="{afed00a8-000b-000c-d1b4-f8e7197d030d}">
           <p14:sldIdLst>
             <p14:sldId id="256"/>
             <p14:sldId id="257"/>
           </p14:sldIdLst>
         </p14:section>
-        <p14:section name="Spiegazione" id="{9a5313e9-7d6a-e0fd-e1bc-00251d9bab75}">
+        <p14:section name="Spiegazione" id="{04599c37-0ac0-2c86-a92b-da233b26dedf}">
           <p14:sldIdLst>
             <p14:sldId id="258"/>
             <p14:sldId id="259"/>
             <p14:sldId id="260"/>
           </p14:sldIdLst>
         </p14:section>
-        <p14:section name="Task" id="{74871b5a-3a61-8bc4-00b6-ada77fd80471}">
+        <p14:section name="Task" id="{eaac964a-964e-d533-c4a1-68fa89a5393e}">
           <p14:sldIdLst>
             <p14:sldId id="261"/>
           </p14:sldIdLst>
         </p14:section>
-        <p14:section name="Chiusura" id="{85b1fe8d-e468-43c9-16fc-569cb9c03a85}">
+        <p14:section name="Chiusura" id="{1b5eed0e-40e0-b0b8-f75c-38da9a9834c8}">
           <p14:sldIdLst>
             <p14:sldId id="262"/>
           </p14:sldIdLst>
@@ -4099,7 +4099,7 @@
                   <a:srgbClr val="F4C06E"/>
                 </a:solidFill>
               </a:rPr>
-              <a:t>Pensa a una domanda per il mini-progetto finale</a:t>
+              <a:t>Compito: scegliete domanda e dati per il mini-progetto</a:t>
             </a:r>
             <a:endParaRPr lang="en-US" sz="2200" dirty="0"/>
           </a:p>

</xml_diff>